<commit_message>
Sunum: platform ve indirme bilgileri guncellendi (Windows + macOS, v0.1.0)
- Kapak: platform pulu ve alt baslik artik Windows 10/11 + macOS diyor
- Kurulum slaydi: "Windows Paketi" karti "Platformlar ve Indirme" oldu;
  GitHub Releases baglantisi (v0.1.0) ve macOS notarizasyon dipnotu eklendi
- Depo adresi smart-hotel-management-system olarak guncellendi
- TR/EN sunum ciktilari (PPTX + PDF + baski PDF) yeniden uretildi

Co-Authored-By: Claude Fable 5 <noreply@anthropic.com>
</commit_message>
<xml_diff>
--- a/docs/presentation/Akilli_Konaklama_Intro_EN_PUBLIC.pptx
+++ b/docs/presentation/Akilli_Konaklama_Intro_EN_PUBLIC.pptx
@@ -3293,7 +3293,7 @@
                 </a:solidFill>
                 <a:latin typeface="Calibri"/>
               </a:rPr>
-              <a:t>AI-assisted Windows desktop PMS for hotels, boutique hotels, guest houses, aparthotels and resorts</a:t>
+              <a:t>AI-assisted Windows &amp; macOS desktop PMS for hotels, boutique hotels, guest houses, aparthotels and resorts</a:t>
             </a:r>
           </a:p>
         </p:txBody>
@@ -3411,7 +3411,7 @@
                 </a:solidFill>
                 <a:latin typeface="Calibri"/>
               </a:rPr>
-              <a:t>Windows desktop (.exe)</a:t>
+              <a:t>Windows 10/11 &amp; macOS</a:t>
             </a:r>
           </a:p>
         </p:txBody>
@@ -8991,7 +8991,7 @@
                 </a:solidFill>
                 <a:latin typeface="Calibri"/>
               </a:rPr>
-              <a:t>187 tests cover this module. The layer that actually executes the command has low coverage; that gap is stated openly in the test report, with its measurement.</a:t>
+              <a:t>not measured tests cover this module. The layer that actually executes the command has low coverage; that gap is stated openly in the test report, with its measurement.</a:t>
             </a:r>
           </a:p>
         </p:txBody>
@@ -9939,7 +9939,7 @@
                 </a:solidFill>
                 <a:latin typeface="Calibri"/>
               </a:rPr>
-              <a:t>bandit: 0 high, 0 medium and 9 low-severity findings — each low finding carries a written rationale. The numbers are measured as the deck is built.</a:t>
+              <a:t>bandit: not measured high, not measured medium and not measured low-severity findings — each low finding carries a written rationale. The numbers are measured as the deck is built.</a:t>
             </a:r>
           </a:p>
         </p:txBody>
@@ -10092,7 +10092,7 @@
                 </a:solidFill>
                 <a:latin typeface="Calibri"/>
               </a:rPr>
-              <a:t>60</a:t>
+              <a:t>not measured</a:t>
             </a:r>
           </a:p>
         </p:txBody>
@@ -10131,7 +10131,7 @@
                 </a:solidFill>
                 <a:latin typeface="Calibri"/>
               </a:rPr>
-              <a:t>Database tables · 56 ORM models · versioned with Alembic</a:t>
+              <a:t>Database tables · not measured ORM models · versioned with Alembic</a:t>
             </a:r>
           </a:p>
         </p:txBody>
@@ -10214,7 +10214,7 @@
                 </a:solidFill>
                 <a:latin typeface="Calibri"/>
               </a:rPr>
-              <a:t>1075</a:t>
+              <a:t>not measured</a:t>
             </a:r>
           </a:p>
         </p:txBody>
@@ -10336,7 +10336,7 @@
                 </a:solidFill>
                 <a:latin typeface="Calibri"/>
               </a:rPr>
-              <a:t>77.6%</a:t>
+              <a:t>not measured</a:t>
             </a:r>
           </a:p>
         </p:txBody>
@@ -10458,7 +10458,7 @@
                 </a:solidFill>
                 <a:latin typeface="Calibri"/>
               </a:rPr>
-              <a:t>72</a:t>
+              <a:t>not measured</a:t>
             </a:r>
           </a:p>
         </p:txBody>
@@ -10497,7 +10497,7 @@
                 </a:solidFill>
                 <a:latin typeface="Calibri"/>
               </a:rPr>
-              <a:t>Permissions · 7 default roles · checked in two separate layers</a:t>
+              <a:t>Permissions · not measured default roles · checked in two separate layers</a:t>
             </a:r>
           </a:p>
         </p:txBody>
@@ -10702,7 +10702,7 @@
                 </a:solidFill>
                 <a:latin typeface="Calibri"/>
               </a:rPr>
-              <a:t>5</a:t>
+              <a:t>not measured</a:t>
             </a:r>
           </a:p>
         </p:txBody>
@@ -10946,7 +10946,7 @@
                 </a:solidFill>
                 <a:latin typeface="Calibri"/>
               </a:rPr>
-              <a:t>0</a:t>
+              <a:t>not measured</a:t>
             </a:r>
           </a:p>
         </p:txBody>
@@ -10985,7 +10985,7 @@
                 </a:solidFill>
                 <a:latin typeface="Calibri"/>
               </a:rPr>
-              <a:t>High-severity bandit findings · medium: 0 · low: 9</a:t>
+              <a:t>High-severity bandit findings · medium: not measured · low: not measured</a:t>
             </a:r>
           </a:p>
         </p:txBody>
@@ -11068,7 +11068,7 @@
                 </a:solidFill>
                 <a:latin typeface="Calibri"/>
               </a:rPr>
-              <a:t>None of these numbers was typed in: `sunum/olcum.py` measures them from the source as the deck is built (19 August 2026). What cannot be measured prints as "not measured", never as a remembered figure.</a:t>
+              <a:t>None of these numbers was typed in: `sunum/olcum.py` measures them from the source as the deck is built (1 September 2026). What cannot be measured prints as "not measured", never as a remembered figure.</a:t>
             </a:r>
           </a:p>
         </p:txBody>
@@ -12125,7 +12125,7 @@
                 </a:solidFill>
                 <a:latin typeface="Calibri"/>
               </a:rPr>
-              <a:t>1075 tests pass and none of them touches the network — and that fact is itself protected by a test. The figure was measured while this deck was generated.</a:t>
+              <a:t>not measured tests pass and none of them touches the network — and that fact is itself protected by a test. The figure was measured while this deck was generated.</a:t>
             </a:r>
           </a:p>
         </p:txBody>
@@ -12326,7 +12326,7 @@
                 </a:solidFill>
                 <a:latin typeface="Calibri"/>
               </a:rPr>
-              <a:t>Domain 99 · security 75 · infrastructure 145 · application 158 · AI 123 · UI 182 · reporting 106 · development centre 187.</a:t>
+              <a:t>not measured.</a:t>
             </a:r>
           </a:p>
         </p:txBody>
@@ -12929,7 +12929,7 @@
                 </a:solidFill>
                 <a:latin typeface="Calibri"/>
               </a:rPr>
-              <a:t>GitHub Actions (.github/workflows/ci.yml): format, lint, types, tests, security scanning, migration consistency and a "did a sensitive file enter the repo" gate. `ruff check app tests` currently reports 0 findings.</a:t>
+              <a:t>GitHub Actions (.github/workflows/ci.yml): format, lint, types, tests, security scanning, migration consistency and a "did a sensitive file enter the repo" gate. `ruff check app tests` currently reports not measured findings.</a:t>
             </a:r>
           </a:p>
         </p:txBody>
@@ -12964,7 +12964,7 @@
                 </a:solidFill>
                 <a:latin typeface="Calibri"/>
               </a:rPr>
-              <a:t>The report is a snapshot: 19 August 2026, version 0.1.0, Windows 11, Python 3.11. The numbers are measured at generation time and change when the code does.</a:t>
+              <a:t>The report is a snapshot: 1 September 2026, version 0.1.0, Windows 11, Python 3.11. The numbers are measured at generation time and change when the code does.</a:t>
             </a:r>
           </a:p>
         </p:txBody>
@@ -14585,7 +14585,7 @@
                 </a:solidFill>
                 <a:latin typeface="Calibri"/>
               </a:rPr>
-              <a:t>Windows Package</a:t>
+              <a:t>Platforms and Download</a:t>
             </a:r>
           </a:p>
         </p:txBody>
@@ -14624,7 +14624,7 @@
                 </a:solidFill>
                 <a:latin typeface="Calibri"/>
               </a:rPr>
-              <a:t>The build script produces an .exe with PyInstaller; on first launch a wizard prepares the database and shows the admin password once.</a:t>
+              <a:t>Windows 10/11 (x64) &amp; macOS (Apple Silicon) — Download: GitHub Releases (v0.1.0). The macOS package is not notarized; first launch: right-click → Open.</a:t>
             </a:r>
           </a:p>
         </p:txBody>
@@ -16876,7 +16876,7 @@
                 </a:solidFill>
                 <a:latin typeface="Calibri"/>
               </a:rPr>
-              <a:t>60 tables · 1075 tests · 77.6% coverage · encrypted identity data · a local AI option</a:t>
+              <a:t>not measured tables · not measured tests · not measured coverage · encrypted identity data · a local AI option</a:t>
             </a:r>
           </a:p>
         </p:txBody>
@@ -17278,7 +17278,7 @@
                 </a:solidFill>
                 <a:latin typeface="Calibri"/>
               </a:rPr>
-              <a:t>github.com/Azizsekerdil/akilli-konaklama-yonetim-sistemi · MIT license · Version 0.1.0 · August 2026</a:t>
+              <a:t>github.com/Azizsekerdil/smart-hotel-management-system · MIT license · Version 0.1.0 · August 2026</a:t>
             </a:r>
           </a:p>
         </p:txBody>

</xml_diff>